<commit_message>
Enforce Inter across Qlik-branded assets (brand_check clean)
qlik-brand brand_check flagged the non-brand mono font 'Consolas' (brand core
allows Inter only). Replace it in the Qlik-branded surfaces:
- gen-project-qlarity-summary.js / gen-agentic-engineering.js: MONO -> Inter
- qlik-doc-styles.js: Qlik doc theme mono -> Inter
- gen-demo-scripts.js: prompt-box font -> Inter

MCG in-world themes (mcg-styles.js, mcg-docx-builder.js) keep Consolas — that
is the fictional company's identity, not Qlik brand. Both decks and the demo
scripts now pass brand_check (0 blocking, 0 warn).

Co-Authored-By: Claude Opus 4.8 <noreply@anthropic.com>
</commit_message>
<xml_diff>
--- a/MCG_Agentic_Data_Engineering.pptx
+++ b/MCG_Agentic_Data_Engineering.pptx
@@ -8429,9 +8429,9 @@
                 <a:solidFill>
                   <a:srgbClr val="10CFC9"/>
                 </a:solidFill>
-                <a:latin typeface="Consolas" pitchFamily="34" charset="0"/>
-                <a:ea typeface="Consolas" pitchFamily="34" charset="-122"/>
-                <a:cs typeface="Consolas" pitchFamily="34" charset="-120"/>
+                <a:latin typeface="Inter" pitchFamily="34" charset="0"/>
+                <a:ea typeface="Inter" pitchFamily="34" charset="-122"/>
+                <a:cs typeface="Inter" pitchFamily="34" charset="-120"/>
               </a:rPr>
               <a:t>git diff — mcg-batch-pipeline / crm-landing</a:t>
             </a:r>
@@ -8468,9 +8468,9 @@
                 <a:solidFill>
                   <a:srgbClr val="D0D4D7"/>
                 </a:solidFill>
-                <a:latin typeface="Consolas" pitchFamily="34" charset="0"/>
-                <a:ea typeface="Consolas" pitchFamily="34" charset="-122"/>
-                <a:cs typeface="Consolas" pitchFamily="34" charset="-120"/>
+                <a:latin typeface="Inter" pitchFamily="34" charset="0"/>
+                <a:ea typeface="Inter" pitchFamily="34" charset="-122"/>
+                <a:cs typeface="Inter" pitchFamily="34" charset="-120"/>
               </a:rPr>
               <a:t>  task: MCG CRM Landing</a:t>
             </a:r>
@@ -8507,9 +8507,9 @@
                 <a:solidFill>
                   <a:srgbClr val="D0D4D7"/>
                 </a:solidFill>
-                <a:latin typeface="Consolas" pitchFamily="34" charset="0"/>
-                <a:ea typeface="Consolas" pitchFamily="34" charset="-122"/>
-                <a:cs typeface="Consolas" pitchFamily="34" charset="-120"/>
+                <a:latin typeface="Inter" pitchFamily="34" charset="0"/>
+                <a:ea typeface="Inter" pitchFamily="34" charset="-122"/>
+                <a:cs typeface="Inter" pitchFamily="34" charset="-120"/>
               </a:rPr>
               <a:t>  schedule:</a:t>
             </a:r>
@@ -8546,9 +8546,9 @@
                 <a:solidFill>
                   <a:srgbClr val="A9B3B6"/>
                 </a:solidFill>
-                <a:latin typeface="Consolas" pitchFamily="34" charset="0"/>
-                <a:ea typeface="Consolas" pitchFamily="34" charset="-122"/>
-                <a:cs typeface="Consolas" pitchFamily="34" charset="-120"/>
+                <a:latin typeface="Inter" pitchFamily="34" charset="0"/>
+                <a:ea typeface="Inter" pitchFamily="34" charset="-122"/>
+                <a:cs typeface="Inter" pitchFamily="34" charset="-120"/>
               </a:rPr>
               <a:t>-   rrule: FREQ=MINUTELY;INTERVAL=15</a:t>
             </a:r>
@@ -8585,9 +8585,9 @@
                 <a:solidFill>
                   <a:srgbClr val="10CFC9"/>
                 </a:solidFill>
-                <a:latin typeface="Consolas" pitchFamily="34" charset="0"/>
-                <a:ea typeface="Consolas" pitchFamily="34" charset="-122"/>
-                <a:cs typeface="Consolas" pitchFamily="34" charset="-120"/>
+                <a:latin typeface="Inter" pitchFamily="34" charset="0"/>
+                <a:ea typeface="Inter" pitchFamily="34" charset="-122"/>
+                <a:cs typeface="Inter" pitchFamily="34" charset="-120"/>
               </a:rPr>
               <a:t>+   rrule: FREQ=MINUTELY;INTERVAL=30</a:t>
             </a:r>
@@ -13503,9 +13503,9 @@
                 <a:solidFill>
                   <a:srgbClr val="FFFFFF"/>
                 </a:solidFill>
-                <a:latin typeface="Consolas" pitchFamily="34" charset="0"/>
-                <a:ea typeface="Consolas" pitchFamily="34" charset="-122"/>
-                <a:cs typeface="Consolas" pitchFamily="34" charset="-120"/>
+                <a:latin typeface="Inter" pitchFamily="34" charset="0"/>
+                <a:ea typeface="Inter" pitchFamily="34" charset="-122"/>
+                <a:cs typeface="Inter" pitchFamily="34" charset="-120"/>
               </a:rPr>
               <a:t>pipeline.yaml</a:t>
             </a:r>

</xml_diff>

<commit_message>
Polish decks: un-stretch Qlik logo, reframe Qlarity as a framework, add notes
- Un-stretch the Qlik logo (true 1.8:1) in every footer and cover across the
  deck family: gen-agentic-engineering, gen-demo-overview, gen-architecture,
  gen-project-qlarity-summary
- Project Qlarity summary: reframe "platform" -> "a framework for demoing the
  full Qlik Cloud stack"; correct deck inventory 6 -> 3 (the marketectures and
  the agentic deck are not counted as core decks); add speaker notes to all 13
  slides
- Regenerate the four affected decks

Co-Authored-By: Claude Opus 4.8 <noreply@anthropic.com>
</commit_message>
<xml_diff>
--- a/MCG_Agentic_Data_Engineering.pptx
+++ b/MCG_Agentic_Data_Engineering.pptx
@@ -2251,7 +2251,7 @@
         <p:spPr>
           <a:xfrm>
             <a:off x="457200" y="365760"/>
-            <a:ext cx="1280160" cy="566928"/>
+            <a:ext cx="1024128" cy="566928"/>
           </a:xfrm>
           <a:prstGeom prst="rect">
             <a:avLst/>
@@ -3030,7 +3030,7 @@
         <p:spPr>
           <a:xfrm>
             <a:off x="457200" y="6492240"/>
-            <a:ext cx="640080" cy="274320"/>
+            <a:ext cx="493776" cy="274320"/>
           </a:xfrm>
           <a:prstGeom prst="rect">
             <a:avLst/>
@@ -3930,7 +3930,7 @@
         <p:spPr>
           <a:xfrm>
             <a:off x="457200" y="6492240"/>
-            <a:ext cx="640080" cy="274320"/>
+            <a:ext cx="493776" cy="274320"/>
           </a:xfrm>
           <a:prstGeom prst="rect">
             <a:avLst/>
@@ -4830,7 +4830,7 @@
         <p:spPr>
           <a:xfrm>
             <a:off x="457200" y="6492240"/>
-            <a:ext cx="640080" cy="274320"/>
+            <a:ext cx="493776" cy="274320"/>
           </a:xfrm>
           <a:prstGeom prst="rect">
             <a:avLst/>
@@ -6314,7 +6314,7 @@
         <p:spPr>
           <a:xfrm>
             <a:off x="457200" y="6492240"/>
-            <a:ext cx="640080" cy="274320"/>
+            <a:ext cx="493776" cy="274320"/>
           </a:xfrm>
           <a:prstGeom prst="rect">
             <a:avLst/>
@@ -7644,7 +7644,7 @@
         <p:spPr>
           <a:xfrm>
             <a:off x="457200" y="6492240"/>
-            <a:ext cx="640080" cy="274320"/>
+            <a:ext cx="493776" cy="274320"/>
           </a:xfrm>
           <a:prstGeom prst="rect">
             <a:avLst/>
@@ -8787,7 +8787,7 @@
         <p:spPr>
           <a:xfrm>
             <a:off x="457200" y="6492240"/>
-            <a:ext cx="640080" cy="274320"/>
+            <a:ext cx="493776" cy="274320"/>
           </a:xfrm>
           <a:prstGeom prst="rect">
             <a:avLst/>
@@ -9853,7 +9853,7 @@
         <p:spPr>
           <a:xfrm>
             <a:off x="457200" y="365760"/>
-            <a:ext cx="1280160" cy="566928"/>
+            <a:ext cx="1024128" cy="566928"/>
           </a:xfrm>
           <a:prstGeom prst="rect">
             <a:avLst/>
@@ -10740,7 +10740,7 @@
         <p:spPr>
           <a:xfrm>
             <a:off x="457200" y="6492240"/>
-            <a:ext cx="640080" cy="274320"/>
+            <a:ext cx="493776" cy="274320"/>
           </a:xfrm>
           <a:prstGeom prst="rect">
             <a:avLst/>
@@ -11229,7 +11229,7 @@
         <p:spPr>
           <a:xfrm>
             <a:off x="457200" y="6492240"/>
-            <a:ext cx="640080" cy="274320"/>
+            <a:ext cx="493776" cy="274320"/>
           </a:xfrm>
           <a:prstGeom prst="rect">
             <a:avLst/>
@@ -12303,7 +12303,7 @@
         <p:spPr>
           <a:xfrm>
             <a:off x="457200" y="6492240"/>
-            <a:ext cx="640080" cy="274320"/>
+            <a:ext cx="493776" cy="274320"/>
           </a:xfrm>
           <a:prstGeom prst="rect">
             <a:avLst/>
@@ -13282,7 +13282,7 @@
         <p:spPr>
           <a:xfrm>
             <a:off x="457200" y="6492240"/>
-            <a:ext cx="640080" cy="274320"/>
+            <a:ext cx="493776" cy="274320"/>
           </a:xfrm>
           <a:prstGeom prst="rect">
             <a:avLst/>
@@ -14311,7 +14311,7 @@
         <p:spPr>
           <a:xfrm>
             <a:off x="457200" y="6492240"/>
-            <a:ext cx="640080" cy="274320"/>
+            <a:ext cx="493776" cy="274320"/>
           </a:xfrm>
           <a:prstGeom prst="rect">
             <a:avLst/>
@@ -15253,7 +15253,7 @@
         <p:spPr>
           <a:xfrm>
             <a:off x="457200" y="6492240"/>
-            <a:ext cx="640080" cy="274320"/>
+            <a:ext cx="493776" cy="274320"/>
           </a:xfrm>
           <a:prstGeom prst="rect">
             <a:avLst/>
@@ -16195,7 +16195,7 @@
         <p:spPr>
           <a:xfrm>
             <a:off x="457200" y="6492240"/>
-            <a:ext cx="640080" cy="274320"/>
+            <a:ext cx="493776" cy="274320"/>
           </a:xfrm>
           <a:prstGeom prst="rect">
             <a:avLst/>
@@ -17137,7 +17137,7 @@
         <p:spPr>
           <a:xfrm>
             <a:off x="457200" y="6492240"/>
-            <a:ext cx="640080" cy="274320"/>
+            <a:ext cx="493776" cy="274320"/>
           </a:xfrm>
           <a:prstGeom prst="rect">
             <a:avLst/>

</xml_diff>